<commit_message>
Remove the enrollment-number placeholder from the deck
The title and closing slides carried a bracketed placeholder that would
have been visible on the uploaded presentation. Replaced with the batch
and programme name.

Co-Authored-By: Claude Opus 5 <noreply@anthropic.com>
</commit_message>
<xml_diff>
--- a/docs/AI-Complaint-Processor-Final-Evaluation.pptx
+++ b/docs/AI-Complaint-Processor-Final-Evaluation.pptx
@@ -2473,7 +2473,7 @@
                 <a:ea typeface="Calibri" pitchFamily="34" charset="-122"/>
                 <a:cs typeface="Calibri" pitchFamily="34" charset="-120"/>
               </a:rPr>
-              <a:t xml:space="preserve">     Enrollment No.  </a:t>
+              <a:t xml:space="preserve">     Batch 1</a:t>
             </a:r>
             <a:pPr indent="0" marL="0">
               <a:buNone/>
@@ -2487,7 +2487,7 @@
                 <a:ea typeface="Calibri" pitchFamily="34" charset="-122"/>
                 <a:cs typeface="Calibri" pitchFamily="34" charset="-120"/>
               </a:rPr>
-              <a:t>[ your enrollment no. ]</a:t>
+              <a:t xml:space="preserve">     GenAI Development Program</a:t>
             </a:r>
             <a:pPr indent="0" marL="0">
               <a:buNone/>
@@ -2501,7 +2501,7 @@
                 <a:ea typeface="Calibri" pitchFamily="34" charset="-122"/>
                 <a:cs typeface="Calibri" pitchFamily="34" charset="-120"/>
               </a:rPr>
-              <a:t xml:space="preserve">     Batch 1</a:t>
+              <a:t xml:space="preserve"> </a:t>
             </a:r>
             <a:endParaRPr lang="en-US" sz="1300" dirty="0"/>
           </a:p>
@@ -9053,7 +9053,7 @@
                 <a:ea typeface="Calibri" pitchFamily="34" charset="-122"/>
                 <a:cs typeface="Calibri" pitchFamily="34" charset="-120"/>
               </a:rPr>
-              <a:t>Harish  ·  Enrollment No. [ your enrollment no. ]  ·  Batch 1  ·  GenAI Development Program</a:t>
+              <a:t>Harish  ·  Batch 1  ·  GenAI Development Program  ·  Final Evaluation, Project 1</a:t>
             </a:r>
             <a:endParaRPr lang="en-US" sz="1150" dirty="0"/>
           </a:p>

</xml_diff>